<commit_message>
Update pitch slides and ignore large local datasets.
Drop the 909MB telemetry zip and other local junk from git so GitHub will accept the push.
</commit_message>
<xml_diff>
--- a/WISL_Pitch_Deck.pptx
+++ b/WISL_Pitch_Deck.pptx
@@ -3757,7 +3757,7 @@
                           </a:solidFill>
                           <a:latin typeface="Garet"/>
                         </a:rPr>
-                        <a:t>POST /v1/flights/{id}/visuals</a:t>
+                        <a:t>POST visuals / GET census</a:t>
                       </a:r>
                     </a:p>
                   </a:txBody>
@@ -3779,7 +3779,7 @@
                           </a:solidFill>
                           <a:latin typeface="Garet"/>
                         </a:rPr>
-                        <a:t>Store a screenshot or camera frame against a flight</a:t>
+                        <a:t>camera_frame store; frame_census on recorded_at for HUD</a:t>
                       </a:r>
                     </a:p>
                   </a:txBody>
@@ -3995,7 +3995,7 @@
                 </a:solidFill>
                 <a:latin typeface="League Spartan"/>
               </a:rPr>
-              <a:t>Five rules, zero brand-specific code.</a:t>
+              <a:t>Physics detectors on L2 JSON. Demo signature is operator_warning.</a:t>
             </a:r>
           </a:p>
         </p:txBody>
@@ -4586,7 +4586,7 @@
                 </a:solidFill>
                 <a:latin typeface="Garet"/>
               </a:rPr>
-              <a:t>Adjacent same-type incidents within 5 seconds merge into one. The ground-speed ceiling is the only brand-dependent value — 120 m/s for anything airborne, 15 m/s once identify_brand() tags the source as a ground rig.</a:t>
+              <a:t>Same-type incidents within 5 s merge. Ground-speed ceiling is the only brand-dependent constant, via identify_brand(). Also: operator_warning from APP.warning; UXO flags mission_incomplete, last_known_position, operator_marked_debris.</a:t>
             </a:r>
           </a:p>
         </p:txBody>
@@ -6616,7 +6616,7 @@
                 </a:solidFill>
                 <a:latin typeface="Garet"/>
               </a:rPr>
-              <a:t>A6 — DATASET: VISION CORPUS</a:t>
+              <a:t>A6  DATASET: VISION CORPUS</a:t>
             </a:r>
           </a:p>
         </p:txBody>
@@ -6650,7 +6650,7 @@
                 </a:solidFill>
                 <a:latin typeface="League Spartan"/>
               </a:rPr>
-              <a:t>VisDrone2019-VID, for the onboard detector.</a:t>
+              <a:t>VisDrone2019-DET stills. Fine-tune set. Not VID. Not telemetry.</a:t>
             </a:r>
           </a:p>
         </p:txBody>
@@ -6720,7 +6720,7 @@
                 </a:solidFill>
                 <a:latin typeface="Garet"/>
               </a:rPr>
-              <a:t>30,836</a:t>
+              <a:t>6471</a:t>
             </a:r>
           </a:p>
         </p:txBody>
@@ -6755,7 +6755,7 @@
                 </a:solidFill>
                 <a:latin typeface="Garet"/>
               </a:rPr>
-              <a:t>ANNOTATED FRAMES</a:t>
+              <a:t>TRAIN STILLS</a:t>
             </a:r>
           </a:p>
         </p:txBody>
@@ -6790,7 +6790,7 @@
                 </a:solidFill>
                 <a:latin typeface="Garet"/>
               </a:rPr>
-              <a:t>56 train + 17 test-dev sequences, 1344×756.</a:t>
+              <a:t>VisDrone2019-DET train, 1:1 txt boxes.</a:t>
             </a:r>
           </a:p>
         </p:txBody>
@@ -6860,7 +6860,7 @@
                 </a:solidFill>
                 <a:latin typeface="Garet"/>
               </a:rPr>
-              <a:t>1.5M</a:t>
+              <a:t>548</a:t>
             </a:r>
           </a:p>
         </p:txBody>
@@ -6895,7 +6895,7 @@
                 </a:solidFill>
                 <a:latin typeface="Garet"/>
               </a:rPr>
-              <a:t>LABELED OBJECTS</a:t>
+              <a:t>VAL</a:t>
             </a:r>
           </a:p>
         </p:txBody>
@@ -6930,7 +6930,7 @@
                 </a:solidFill>
                 <a:latin typeface="Garet"/>
               </a:rPr>
-              <a:t>Cars, pedestrians, motorbikes, cyclists, from a drone camera.</a:t>
+              <a:t>mAP gate. finetune_eval.json is still dry_run.</a:t>
             </a:r>
           </a:p>
         </p:txBody>
@@ -7000,7 +7000,7 @@
                 </a:solidFill>
                 <a:latin typeface="Garet"/>
               </a:rPr>
-              <a:t>100%</a:t>
+              <a:t>1610</a:t>
             </a:r>
           </a:p>
         </p:txBody>
@@ -7035,7 +7035,7 @@
                 </a:solidFill>
                 <a:latin typeface="Garet"/>
               </a:rPr>
-              <a:t>INTEGRITY MATCH</a:t>
+              <a:t>TEST-DEV</a:t>
             </a:r>
           </a:p>
         </p:txBody>
@@ -7070,7 +7070,7 @@
                 </a:solidFill>
                 <a:latin typeface="Garet"/>
               </a:rPr>
-              <a:t>Every sequence's frame count matches its annotation file, no gaps.</a:t>
+              <a:t>Hold-out after val. Drop class 0 ignored regions.</a:t>
             </a:r>
           </a:p>
         </p:txBody>
@@ -7210,7 +7210,7 @@
                 </a:solidFill>
                 <a:latin typeface="Garet"/>
               </a:rPr>
-              <a:t>Same incident timeline, new visual-record kind, in progress.</a:t>
+              <a:t>frame_census on recorded_at. HUD cars N · people M.</a:t>
             </a:r>
           </a:p>
         </p:txBody>
@@ -7444,7 +7444,7 @@
                           </a:solidFill>
                           <a:latin typeface="Garet"/>
                         </a:rPr>
-                        <a:t>Detection</a:t>
+                        <a:t>Physics detect</a:t>
                       </a:r>
                     </a:p>
                   </a:txBody>
@@ -7466,7 +7466,7 @@
                           </a:solidFill>
                           <a:latin typeface="Garet"/>
                         </a:rPr>
-                        <a:t>Pure stdlib Python — no model, no training data</a:t>
+                        <a:t>stdlib thresholds on L2 JSON</a:t>
                       </a:r>
                     </a:p>
                   </a:txBody>
@@ -7597,7 +7597,7 @@
                           </a:solidFill>
                           <a:latin typeface="Garet"/>
                         </a:rPr>
-                        <a:t>Storage</a:t>
+                        <a:t>Storage / vision</a:t>
                       </a:r>
                     </a:p>
                   </a:txBody>
@@ -7619,7 +7619,7 @@
                           </a:solidFill>
                           <a:latin typeface="Garet"/>
                         </a:rPr>
-                        <a:t>SQLite records, file-based visual asset store</a:t>
+                        <a:t>SQLite + visuals_dir. Optional YOLOv8n sidecar; frame_census HUD.</a:t>
                       </a:r>
                     </a:p>
                   </a:txBody>
@@ -7835,7 +7835,7 @@
                 </a:solidFill>
                 <a:latin typeface="Garet"/>
               </a:rPr>
-              <a:t>Why thresholds, not machine learning?</a:t>
+              <a:t>Why thresholds for aircraft health?</a:t>
             </a:r>
           </a:p>
         </p:txBody>
@@ -7870,7 +7870,7 @@
                 </a:solidFill>
                 <a:latin typeface="Garet"/>
               </a:rPr>
-              <a:t>Explainable, needs no training data, runs identically across brands, and the numbers are grounded in published specs, not guesses.</a:t>
+              <a:t>Explainable, identical across brands, grounded in published failsafe bands. ML is reserved for ground-object census.</a:t>
             </a:r>
           </a:p>
         </p:txBody>
@@ -8080,7 +8080,7 @@
                 </a:solidFill>
                 <a:latin typeface="Garet"/>
               </a:rPr>
-              <a:t>Not yet tested against a real binary log — the one open validation gap, called out on purpose.</a:t>
+              <a:t>Parsers and tests exist on real files in raw_telemetry-datasets/ (3 ULog, 2 DataFlash, 1 tlog).</a:t>
             </a:r>
           </a:p>
         </p:txBody>
@@ -8290,7 +8290,7 @@
                 </a:solidFill>
                 <a:latin typeface="Garet"/>
               </a:rPr>
-              <a:t>Same incident timeline, a new camera_frame record — the detector itself isn't wired up yet.</a:t>
+              <a:t>HUD and census API are wired. VisDrone DET fine-tune has not been run. No onboard detector. No globe-projected boxes.</a:t>
             </a:r>
           </a:p>
         </p:txBody>
@@ -10705,7 +10705,7 @@
                 </a:solidFill>
                 <a:latin typeface="Garet"/>
               </a:rPr>
-              <a:t>04 — VALIDATED, NOT JUST SYNTHETIC</a:t>
+              <a:t>04  WHAT WE ACTUALLY RAN</a:t>
             </a:r>
           </a:p>
         </p:txBody>
@@ -10739,7 +10739,7 @@
                 </a:solidFill>
                 <a:latin typeface="League Spartan"/>
               </a:rPr>
-              <a:t>Run against four real datasets this quarter.</a:t>
+              <a:t>Counts are files the parsers accept. Demo uses a subset.</a:t>
             </a:r>
           </a:p>
         </p:txBody>
@@ -10809,7 +10809,7 @@
                 </a:solidFill>
                 <a:latin typeface="Garet"/>
               </a:rPr>
-              <a:t>554</a:t>
+              <a:t>2</a:t>
             </a:r>
           </a:p>
         </p:txBody>
@@ -10844,7 +10844,7 @@
                 </a:solidFill>
                 <a:latin typeface="Garet"/>
               </a:rPr>
-              <a:t>REAL MISSION LOGS</a:t>
+              <a:t>DJI CSV DEMO</a:t>
             </a:r>
           </a:p>
         </p:txBody>
@@ -10879,7 +10879,7 @@
                 </a:solidFill>
                 <a:latin typeface="Garet"/>
               </a:rPr>
-              <a:t>Operations log CSV</a:t>
+              <a:t>alpha + bravo controller fixtures</a:t>
             </a:r>
           </a:p>
         </p:txBody>
@@ -10914,7 +10914,7 @@
                 </a:solidFill>
                 <a:latin typeface="Garet"/>
               </a:rPr>
-              <a:t>0 false positives on 547 completed flights.</a:t>
+              <a:t>Recurring operator_warning. min_flights=2.</a:t>
             </a:r>
           </a:p>
         </p:txBody>
@@ -10984,7 +10984,7 @@
                 </a:solidFill>
                 <a:latin typeface="Garet"/>
               </a:rPr>
-              <a:t>785</a:t>
+              <a:t>3</a:t>
             </a:r>
           </a:p>
         </p:txBody>
@@ -11019,7 +11019,7 @@
                 </a:solidFill>
                 <a:latin typeface="Garet"/>
               </a:rPr>
-              <a:t>REAL TELEMETRY SAMPLES</a:t>
+              <a:t>PX4 ULOG</a:t>
             </a:r>
           </a:p>
         </p:txBody>
@@ -11054,7 +11054,7 @@
                 </a:solidFill>
                 <a:latin typeface="Garet"/>
               </a:rPr>
-              <a:t>2 flights, live GPS + battery</a:t>
+              <a:t>recorded .ulg on disk</a:t>
             </a:r>
           </a:p>
         </p:txBody>
@@ -11089,7 +11089,7 @@
                 </a:solidFill>
                 <a:latin typeface="Garet"/>
               </a:rPr>
-              <a:t>0 incidents on 2 clean flights, all within limits.</a:t>
+              <a:t>pytest parse_px4_ulg_to_l1 on the sample ULog.</a:t>
             </a:r>
           </a:p>
         </p:txBody>
@@ -11159,7 +11159,7 @@
                 </a:solidFill>
                 <a:latin typeface="Garet"/>
               </a:rPr>
-              <a:t>1,853</a:t>
+              <a:t>2+1</a:t>
             </a:r>
           </a:p>
         </p:txBody>
@@ -11194,7 +11194,7 @@
                 </a:solidFill>
                 <a:latin typeface="Garet"/>
               </a:rPr>
-              <a:t>REAL DJI WARNINGS</a:t>
+              <a:t>ARDUPILOT</a:t>
             </a:r>
           </a:p>
         </p:txBody>
@@ -11229,7 +11229,7 @@
                 </a:solidFill>
                 <a:latin typeface="Garet"/>
               </a:rPr>
-              <a:t>12 DJI models, DroneNLP corpus</a:t>
+              <a:t>DataFlash .bin + MAVLink .tlog</a:t>
             </a:r>
           </a:p>
         </p:txBody>
@@ -11264,7 +11264,7 @@
                 </a:solidFill>
                 <a:latin typeface="Garet"/>
               </a:rPr>
-              <a:t>683 messages matched our warning keywords.</a:t>
+              <a:t>pytest: crash bin, log171.bin, flight.tlog.</a:t>
             </a:r>
           </a:p>
         </p:txBody>
@@ -11334,7 +11334,7 @@
                 </a:solidFill>
                 <a:latin typeface="Garet"/>
               </a:rPr>
-              <a:t>30,836</a:t>
+              <a:t>6471</a:t>
             </a:r>
           </a:p>
         </p:txBody>
@@ -11369,7 +11369,7 @@
                 </a:solidFill>
                 <a:latin typeface="Garet"/>
               </a:rPr>
-              <a:t>ANNOTATED CAMERA FRAMES</a:t>
+              <a:t>VISDRONE DET</a:t>
             </a:r>
           </a:p>
         </p:txBody>
@@ -11404,7 +11404,7 @@
                 </a:solidFill>
                 <a:latin typeface="Garet"/>
               </a:rPr>
-              <a:t>VisDrone2019-VID, 1.5M+ boxes</a:t>
+              <a:t>6471 train / 548 val stills</a:t>
             </a:r>
           </a:p>
         </p:txBody>
@@ -11439,7 +11439,7 @@
                 </a:solidFill>
                 <a:latin typeface="Garet"/>
               </a:rPr>
-              <a:t>Training data secured for the vision layer.</a:t>
+              <a:t>camera_frame + frame_census on recorded_at.</a:t>
             </a:r>
           </a:p>
         </p:txBody>
@@ -11536,7 +11536,7 @@
                 </a:solidFill>
                 <a:latin typeface="Garet"/>
               </a:rPr>
-              <a:t>05 — THE DEMO, END TO END</a:t>
+              <a:t>05  THE DEMO</a:t>
             </a:r>
           </a:p>
         </p:txBody>
@@ -11570,7 +11570,7 @@
                 </a:solidFill>
                 <a:latin typeface="League Spartan"/>
               </a:rPr>
-              <a:t>Raw log in. 3D reconstruction and a fleet bulletin out.</a:t>
+              <a:t>Upload a raw log. GET /v1/flights/{id}/path drives Cesium.</a:t>
             </a:r>
           </a:p>
         </p:txBody>
@@ -11685,7 +11685,7 @@
                 </a:solidFill>
                 <a:latin typeface="Garet"/>
               </a:rPr>
-              <a:t>Flight path, 10 incidents flagged:</a:t>
+              <a:t>Two DJI CSVs. Both emit operator_warning.</a:t>
             </a:r>
           </a:p>
         </p:txBody>
@@ -11720,7 +11720,7 @@
                 </a:solidFill>
                 <a:latin typeface="Garet"/>
               </a:rPr>
-              <a:t>● Critical × 4        ○ Warning × 6</a:t>
+              <a:t>GPS signal weak on alpha and bravo</a:t>
             </a:r>
           </a:p>
         </p:txBody>
@@ -11755,7 +11755,7 @@
                 </a:solidFill>
                 <a:latin typeface="Garet"/>
               </a:rPr>
-              <a:t>2 battery_critical · 2 battery_low · 3 battery_plunge · 3 telemetry_gap</a:t>
+              <a:t>GET /v1/incidents/patterns at min_flights=2</a:t>
             </a:r>
           </a:p>
         </p:txBody>
@@ -11825,7 +11825,7 @@
                 </a:solidFill>
                 <a:latin typeface="Garet"/>
               </a:rPr>
-              <a:t>SINGLE FLIGHT</a:t>
+              <a:t>PATH</a:t>
             </a:r>
           </a:p>
         </p:txBody>
@@ -11860,7 +11860,7 @@
                 </a:solidFill>
                 <a:latin typeface="Garet"/>
               </a:rPr>
-              <a:t>Trajectory animated from /v1/flights/{id}/path; 10 incidents flagged at their timestamps.</a:t>
+              <a:t>Trajectory from /v1/flights/{id}/path on the recorded clock.</a:t>
             </a:r>
           </a:p>
         </p:txBody>
@@ -11930,7 +11930,7 @@
                 </a:solidFill>
                 <a:latin typeface="Garet"/>
               </a:rPr>
-              <a:t>SIGNATURE RECURS ≥2 FLIGHTS</a:t>
+              <a:t>SIGNATURE RECURS AT 2 FLIGHTS</a:t>
             </a:r>
           </a:p>
         </p:txBody>
@@ -11965,7 +11965,7 @@
                 </a:solidFill>
                 <a:latin typeface="Garet"/>
               </a:rPr>
-              <a:t>Surfaces on /v1/incidents/patterns — flight count, incident count, first/last seen.</a:t>
+              <a:t>patterns: flight count, incident count, first/last seen.</a:t>
             </a:r>
           </a:p>
         </p:txBody>
@@ -12070,7 +12070,7 @@
                 </a:solidFill>
                 <a:latin typeface="Garet"/>
               </a:rPr>
-              <a:t>Affected flights, what to check, what to brief — a reviewable document, not a firmware push.</a:t>
+              <a:t>POST /v1/mitigation-bulletins writes an operator briefing document.</a:t>
             </a:r>
           </a:p>
         </p:txBody>
@@ -12167,7 +12167,7 @@
                 </a:solidFill>
                 <a:latin typeface="Garet"/>
               </a:rPr>
-              <a:t>06 — WHAT'S NEXT, HONESTLY</a:t>
+              <a:t>06  FUTURE EXPANSION</a:t>
             </a:r>
           </a:p>
         </p:txBody>
@@ -12201,7 +12201,7 @@
                 </a:solidFill>
                 <a:latin typeface="League Spartan"/>
               </a:rPr>
-              <a:t>Two things we haven't closed yet.</a:t>
+              <a:t>Fine-tune is still a dry-run. Landing-zone occupancy is next.</a:t>
             </a:r>
           </a:p>
         </p:txBody>
@@ -12306,7 +12306,7 @@
                 </a:solidFill>
                 <a:latin typeface="Garet"/>
               </a:rPr>
-              <a:t>Raw binary formats</a:t>
+              <a:t>VisDrone DET fine-tune</a:t>
             </a:r>
           </a:p>
         </p:txBody>
@@ -12341,7 +12341,7 @@
                 </a:solidFill>
                 <a:latin typeface="Garet"/>
               </a:rPr>
-              <a:t>A real PX4 ULog or ArduPilot DataFlash file carries format idiosyncrasies synthetic data can't surface. The normalizer needs to meet one in the wild.</a:t>
+              <a:t>finetune_eval.json is dry_run true. mAP50 is null. YOLOv8n stays COCO-pretrained. No edge weights.</a:t>
             </a:r>
           </a:p>
         </p:txBody>
@@ -12411,7 +12411,7 @@
                 </a:solidFill>
                 <a:latin typeface="Garet"/>
               </a:rPr>
-              <a:t>IN PROGRESS</a:t>
+              <a:t>NEXT</a:t>
             </a:r>
           </a:p>
         </p:txBody>
@@ -12446,7 +12446,7 @@
                 </a:solidFill>
                 <a:latin typeface="Garet"/>
               </a:rPr>
-              <a:t>A vision layer</a:t>
+              <a:t>Landing-zone occupancy</a:t>
             </a:r>
           </a:p>
         </p:txBody>
@@ -12481,7 +12481,7 @@
                 </a:solidFill>
                 <a:latin typeface="Garet"/>
               </a:rPr>
-              <a:t>30,000+ annotated camera frames are already in hand to train an onboard object detector, feeding the same incident timeline as a stored camera frame.</a:t>
+              <a:t>Combine frame_census with altitude from L2. Globe-projected boxes stay out until camera intrinsics exist on the log.</a:t>
             </a:r>
           </a:p>
         </p:txBody>
@@ -12881,7 +12881,7 @@
                 </a:solidFill>
                 <a:latin typeface="Garet"/>
               </a:rPr>
-              <a:t>Architecture, detection logic, and the four datasets behind the numbers — kept out of the main pitch, kept ready for questions.</a:t>
+              <a:t>Architecture, detection, stack, vision corpus. A3-A5 stay as offline looks, not ingest proof.</a:t>
             </a:r>
           </a:p>
         </p:txBody>

</xml_diff>